<commit_message>
System Design 101 (vi): public-key verification wording in sd-08-013, backoff scope in sd-08-014
Co-Authored-By: Claude Sonnet 5.5 <noreply@anthropic.com>
Claude-Session: https://claude.ai/code/session_01DkN7YTqFfdjb8A8J5ehSWS
</commit_message>
<xml_diff>
--- a/system-design-101/vi/lessons/sd-08-013/slides/sd-08-013.pptx
+++ b/system-design-101/vi/lessons/sd-08-013/slides/sd-08-013.pptx
@@ -8829,6 +8829,17 @@
               <a:t> sẻ;</a:t>
             </a:r>
             <a:r>
+              <a:rPr lang="en-US" sz="2250" dirty="0" spc="-2" kern="0">
+                <a:solidFill>
+                  <a:srgbClr val="E4E1D8"/>
+                </a:solidFill>
+                <a:latin typeface="Be Vietnam Pro" pitchFamily="34" charset="0"/>
+                <a:ea typeface="Be Vietnam Pro" pitchFamily="34" charset="-122"/>
+                <a:cs typeface="Be Vietnam Pro" pitchFamily="34" charset="-120"/>
+              </a:rPr>
+              <a:t> kiểm bằng</a:t>
+            </a:r>
+            <a:r>
               <a:rPr lang="en-US" sz="2250" dirty="0" spc="-4" kern="0">
                 <a:solidFill>
                   <a:srgbClr val="E4E1D8"/>
@@ -8862,6 +8873,50 @@
               <a:t> khai</a:t>
             </a:r>
             <a:r>
+              <a:rPr lang="en-US" sz="2250" dirty="0" spc="1" kern="0">
+                <a:solidFill>
+                  <a:srgbClr val="E4E1D8"/>
+                </a:solidFill>
+                <a:latin typeface="Be Vietnam Pro" pitchFamily="34" charset="0"/>
+                <a:ea typeface="Be Vietnam Pro" pitchFamily="34" charset="-122"/>
+                <a:cs typeface="Be Vietnam Pro" pitchFamily="34" charset="-120"/>
+              </a:rPr>
+              <a:t> (ký</a:t>
+            </a:r>
+            <a:r>
+              <a:rPr lang="en-US" sz="2250" dirty="0" spc="-2" kern="0">
+                <a:solidFill>
+                  <a:srgbClr val="E4E1D8"/>
+                </a:solidFill>
+                <a:latin typeface="Be Vietnam Pro" pitchFamily="34" charset="0"/>
+                <a:ea typeface="Be Vietnam Pro" pitchFamily="34" charset="-122"/>
+                <a:cs typeface="Be Vietnam Pro" pitchFamily="34" charset="-120"/>
+              </a:rPr>
+              <a:t> bằng</a:t>
+            </a:r>
+            <a:r>
+              <a:rPr lang="en-US" sz="2250" dirty="0" spc="-4" kern="0">
+                <a:solidFill>
+                  <a:srgbClr val="E4E1D8"/>
+                </a:solidFill>
+                <a:latin typeface="Be Vietnam Pro" pitchFamily="34" charset="0"/>
+                <a:ea typeface="Be Vietnam Pro" pitchFamily="34" charset="-122"/>
+                <a:cs typeface="Be Vietnam Pro" pitchFamily="34" charset="-120"/>
+              </a:rPr>
+              <a:t> khoá</a:t>
+            </a:r>
+            <a:r>
+              <a:rPr lang="en-US" sz="2250" dirty="0" spc="5" kern="0">
+                <a:solidFill>
+                  <a:srgbClr val="E4E1D8"/>
+                </a:solidFill>
+                <a:latin typeface="Be Vietnam Pro" pitchFamily="34" charset="0"/>
+                <a:ea typeface="Be Vietnam Pro" pitchFamily="34" charset="-122"/>
+                <a:cs typeface="Be Vietnam Pro" pitchFamily="34" charset="-120"/>
+              </a:rPr>
+              <a:t> riêng)</a:t>
+            </a:r>
+            <a:r>
               <a:rPr lang="en-US" sz="2250" dirty="0" spc="0" kern="0">
                 <a:solidFill>
                   <a:srgbClr val="E4E1D8"/>
@@ -8870,18 +8925,7 @@
                 <a:ea typeface="Be Vietnam Pro" pitchFamily="34" charset="-122"/>
                 <a:cs typeface="Be Vietnam Pro" pitchFamily="34" charset="-120"/>
               </a:rPr>
-              <a:t> đắt</a:t>
-            </a:r>
-            <a:r>
-              <a:rPr lang="en-US" sz="2250" dirty="0" spc="1" kern="0">
-                <a:solidFill>
-                  <a:srgbClr val="E4E1D8"/>
-                </a:solidFill>
-                <a:latin typeface="Be Vietnam Pro" pitchFamily="34" charset="0"/>
-                <a:ea typeface="Be Vietnam Pro" pitchFamily="34" charset="-122"/>
-                <a:cs typeface="Be Vietnam Pro" pitchFamily="34" charset="-120"/>
-              </a:rPr>
-              <a:t> hơn</a:t>
+              <a:t> đắt hơn</a:t>
             </a:r>
             <a:endParaRPr lang="en-US" sz="2250" dirty="0"/>
           </a:p>

</xml_diff>

<commit_message>
System Design 101 (vi): count six measured and three unmeasured components in sd-08-013
</commit_message>
<xml_diff>
--- a/system-design-101/vi/lessons/sd-08-013/slides/sd-08-013.pptx
+++ b/system-design-101/vi/lessons/sd-08-013/slides/sd-08-013.pptx
@@ -1918,6 +1918,17 @@
               <a:t> máy,</a:t>
             </a:r>
             <a:r>
+              <a:rPr lang="en-US" sz="3000" dirty="0" spc="-3" kern="0">
+                <a:solidFill>
+                  <a:srgbClr val="E4E1D8"/>
+                </a:solidFill>
+                <a:latin typeface="Be Vietnam Pro" pitchFamily="34" charset="0"/>
+                <a:ea typeface="Be Vietnam Pro" pitchFamily="34" charset="-122"/>
+                <a:cs typeface="Be Vietnam Pro" pitchFamily="34" charset="-120"/>
+              </a:rPr>
+              <a:t> ba</a:t>
+            </a:r>
+            <a:r>
               <a:rPr lang="en-US" sz="3000" dirty="0" spc="-2" kern="0">
                 <a:solidFill>
                   <a:srgbClr val="E4E1D8"/>
@@ -1926,10 +1937,10 @@
                 <a:ea typeface="Be Vietnam Pro" pitchFamily="34" charset="-122"/>
                 <a:cs typeface="Be Vietnam Pro" pitchFamily="34" charset="-120"/>
               </a:rPr>
-              <a:t> bốn thành</a:t>
-            </a:r>
-            <a:r>
-              <a:rPr lang="en-US" sz="3000" dirty="0" spc="-1" kern="0">
+              <a:t> thành</a:t>
+            </a:r>
+            <a:r>
+              <a:rPr lang="en-US" sz="3000" dirty="0" spc="0" kern="0">
                 <a:solidFill>
                   <a:srgbClr val="E4E1D8"/>
                 </a:solidFill>
@@ -1940,7 +1951,7 @@
               <a:t> phần</a:t>
             </a:r>
             <a:r>
-              <a:rPr lang="en-US" sz="3000" dirty="0" spc="11" kern="0">
+              <a:rPr lang="en-US" sz="3000" dirty="0" spc="10" kern="0">
                 <a:solidFill>
                   <a:srgbClr val="E4E1D8"/>
                 </a:solidFill>
@@ -1951,7 +1962,7 @@
               <a:t> chưa</a:t>
             </a:r>
             <a:r>
-              <a:rPr lang="en-US" sz="3000" dirty="0" spc="14" kern="0">
+              <a:rPr lang="en-US" sz="3000" dirty="0" spc="15" kern="0">
                 <a:solidFill>
                   <a:srgbClr val="E4E1D8"/>
                 </a:solidFill>
@@ -7080,7 +7091,7 @@
               <a:t>Còn</a:t>
             </a:r>
             <a:r>
-              <a:rPr lang="en-US" sz="6900" dirty="0" spc="1" kern="0">
+              <a:rPr lang="en-US" sz="6900" dirty="0" spc="-5" kern="0">
                 <a:solidFill>
                   <a:srgbClr val="14161C"/>
                 </a:solidFill>
@@ -7088,7 +7099,7 @@
                 <a:ea typeface="Bricolage Grotesque ExtraBold" pitchFamily="34" charset="-122"/>
                 <a:cs typeface="Bricolage Grotesque ExtraBold" pitchFamily="34" charset="-120"/>
               </a:rPr>
-              <a:t> bốn</a:t>
+              <a:t> ba</a:t>
             </a:r>
             <a:r>
               <a:rPr lang="en-US" sz="6900" dirty="0" spc="2" kern="0">
@@ -7144,7 +7155,7 @@
               <a:buNone/>
             </a:pPr>
             <a:r>
-              <a:rPr lang="en-US" sz="31500" dirty="0" spc="-4" kern="0">
+              <a:rPr lang="en-US" sz="31500" dirty="0" spc="-3" kern="0">
                 <a:solidFill>
                   <a:srgbClr val="E8472B"/>
                 </a:solidFill>
@@ -7152,7 +7163,7 @@
                 <a:ea typeface="Bricolage Grotesque ExtraBold" pitchFamily="34" charset="-122"/>
                 <a:cs typeface="Bricolage Grotesque ExtraBold" pitchFamily="34" charset="-120"/>
               </a:rPr>
-              <a:t>4</a:t>
+              <a:t>3</a:t>
             </a:r>
             <a:endParaRPr lang="en-US" sz="31500" dirty="0"/>
           </a:p>
@@ -7513,7 +7524,7 @@
               <a:buNone/>
             </a:pPr>
             <a:r>
-              <a:rPr lang="en-US" sz="2550" dirty="0" spc="-87" kern="0">
+              <a:rPr lang="en-US" sz="2550" dirty="0" spc="-4" kern="0">
                 <a:solidFill>
                   <a:srgbClr val="14161C"/>
                 </a:solidFill>
@@ -7521,10 +7532,10 @@
                 <a:ea typeface="Be Vietnam Pro ExtraBold" pitchFamily="34" charset="-122"/>
                 <a:cs typeface="Be Vietnam Pro ExtraBold" pitchFamily="34" charset="-120"/>
               </a:rPr>
-              <a:t>Vẽ</a:t>
-            </a:r>
-            <a:r>
-              <a:rPr lang="en-US" sz="2550" dirty="0" spc="0" kern="0">
+              <a:t>Cũng</a:t>
+            </a:r>
+            <a:r>
+              <a:rPr lang="en-US" sz="2550" dirty="0" spc="10" kern="0">
                 <a:solidFill>
                   <a:srgbClr val="14161C"/>
                 </a:solidFill>
@@ -7532,10 +7543,10 @@
                 <a:ea typeface="Be Vietnam Pro ExtraBold" pitchFamily="34" charset="-122"/>
                 <a:cs typeface="Be Vietnam Pro ExtraBold" pitchFamily="34" charset="-120"/>
               </a:rPr>
-              <a:t> biểu</a:t>
-            </a:r>
-            <a:r>
-              <a:rPr lang="en-US" sz="2550" dirty="0" spc="2" kern="0">
+              <a:t> chưa</a:t>
+            </a:r>
+            <a:r>
+              <a:rPr lang="en-US" sz="2550" dirty="0" spc="3" kern="0">
                 <a:solidFill>
                   <a:srgbClr val="14161C"/>
                 </a:solidFill>
@@ -7543,10 +7554,10 @@
                 <a:ea typeface="Be Vietnam Pro ExtraBold" pitchFamily="34" charset="-122"/>
                 <a:cs typeface="Be Vietnam Pro ExtraBold" pitchFamily="34" charset="-120"/>
               </a:rPr>
-              <a:t> đồ</a:t>
-            </a:r>
-            <a:r>
-              <a:rPr lang="en-US" sz="2550" dirty="0" spc="-22" kern="0">
+              <a:t> đo:</a:t>
+            </a:r>
+            <a:r>
+              <a:rPr lang="en-US" sz="2550" dirty="0" spc="-23" kern="0">
                 <a:solidFill>
                   <a:srgbClr val="14161C"/>
                 </a:solidFill>
@@ -7554,7 +7565,18 @@
                 <a:ea typeface="Be Vietnam Pro ExtraBold" pitchFamily="34" charset="-122"/>
                 <a:cs typeface="Be Vietnam Pro ExtraBold" pitchFamily="34" charset="-120"/>
               </a:rPr>
-              <a:t> và</a:t>
+              <a:t> vẽ</a:t>
+            </a:r>
+            <a:r>
+              <a:rPr lang="en-US" sz="2550" dirty="0" spc="0" kern="0">
+                <a:solidFill>
+                  <a:srgbClr val="14161C"/>
+                </a:solidFill>
+                <a:latin typeface="Be Vietnam Pro ExtraBold" pitchFamily="34" charset="0"/>
+                <a:ea typeface="Be Vietnam Pro ExtraBold" pitchFamily="34" charset="-122"/>
+                <a:cs typeface="Be Vietnam Pro ExtraBold" pitchFamily="34" charset="-120"/>
+              </a:rPr>
+              <a:t> biểu đồ,</a:t>
             </a:r>
             <a:r>
               <a:rPr lang="en-US" sz="2550" dirty="0" spc="1" kern="0">

</xml_diff>

<commit_message>
System Design 101 (vi): say the token-check timing excludes revocation and permission freshness in sd-08-013
</commit_message>
<xml_diff>
--- a/system-design-101/vi/lessons/sd-08-013/slides/sd-08-013.pptx
+++ b/system-design-101/vi/lessons/sd-08-013/slides/sd-08-013.pptx
@@ -5915,6 +5915,28 @@
                 <a:cs typeface="Be Vietnam Pro" pitchFamily="34" charset="-120"/>
               </a:rPr>
               <a:t> 1,8</a:t>
+            </a:r>
+            <a:r>
+              <a:rPr lang="en-US" sz="2100" dirty="0" spc="-1" kern="0">
+                <a:solidFill>
+                  <a:srgbClr val="E4E1D8"/>
+                </a:solidFill>
+                <a:latin typeface="Be Vietnam Pro" pitchFamily="34" charset="0"/>
+                <a:ea typeface="Be Vietnam Pro" pitchFamily="34" charset="-122"/>
+                <a:cs typeface="Be Vietnam Pro" pitchFamily="34" charset="-120"/>
+              </a:rPr>
+              <a:t> (chỉ thời</a:t>
+            </a:r>
+            <a:r>
+              <a:rPr lang="en-US" sz="2100" dirty="0" spc="0" kern="0">
+                <a:solidFill>
+                  <a:srgbClr val="E4E1D8"/>
+                </a:solidFill>
+                <a:latin typeface="Be Vietnam Pro" pitchFamily="34" charset="0"/>
+                <a:ea typeface="Be Vietnam Pro" pitchFamily="34" charset="-122"/>
+                <a:cs typeface="Be Vietnam Pro" pitchFamily="34" charset="-120"/>
+              </a:rPr>
+              <a:t> gian)</a:t>
             </a:r>
             <a:endParaRPr lang="en-US" sz="2100" dirty="0"/>
           </a:p>

</xml_diff>